<commit_message>
feat(report): plain AWS logo on the executive deck title slide
Problem: the title-slide logo (Picture 3 on the "Default" layout) was the
"aws migrations" lockup (ppt/media/image3.png) cropped with
srcRect r="55119" down to its "aws" half. The deck is meant to carry the
generic AWS logo, and the PDF renderer, which ignores crops (#240), showed
the full "aws migrations" wordmark squeezed into the frame.

Fix: point the logo at the plain AWS logo already in the package
(ppt/media/image1.png, the footer logo), drop the crop, and size it 1.1in
wide at the image's own aspect ratio, same position. image3.png had no
other referrer, so it and its relationship are removed from the template.

Tests: slide 1's logo resolves to /ppt/media/image1.png, is uncropped and
unstretched, and image3.png is not packaged.

Refs #181
</commit_message>
<xml_diff>
--- a/src/report/assets/template.pptx
+++ b/src/report/assets/template.pptx
@@ -1246,14 +1246,13 @@
           <p:nvPr/>
         </p:nvPicPr>
         <p:blipFill>
-          <a:blip r:embed="rId4"/>
-          <a:srcRect r="55119"/>
+          <a:blip r:embed="rId2"/>
           <a:stretch/>
         </p:blipFill>
         <p:spPr>
           <a:xfrm>
             <a:off x="612720" y="502920"/>
-            <a:ext cx="1164960" cy="739800"/>
+            <a:ext cx="1005840" cy="601535"/>
           </a:xfrm>
           <a:prstGeom prst="rect">
             <a:avLst/>

</xml_diff>